<commit_message>
Improve Amazon checkout UX case study and Penpot design
</commit_message>
<xml_diff>
--- a/assignment/amazon-india-web-checkout-ux-evaluation.pptx
+++ b/assignment/amazon-india-web-checkout-ux-evaluation.pptx
@@ -648,7 +648,7 @@
           <a:lstStyle/>
           <a:p>
             <a:r>
-              <a:t>Original screenshots: evidence/cart-item.jpg, evidence/payment-methods.jpg, evidence/review-total.jpg, evidence/order-confirmation.jpg and evidence/cancellation-success.jpg. All were captured from the signed-in desktop web flow on 20 October 2026. Public crops exclude personal account information. Screenshot evidence establishes visible states, not participant friction.</a:t>
+              <a:t>Original screenshots: evidence/cart-item.jpg, evidence/payment-methods.jpg, evidence/review-total.jpg, evidence/order-confirmation.jpg and evidence/cancellation-success.jpg. All were captured from the signed-in desktop web flow on 20 October 2026. Public crops exclude personal account information. Display copies of payment, review and cancellation remove cursor artifacts only; originals remain in the evidence folder. Screenshot evidence establishes visible states, not participant friction.</a:t>
             </a:r>
           </a:p>
         </p:txBody>
@@ -6060,7 +6060,7 @@
       </p:sp>
       <p:pic>
         <p:nvPicPr>
-          <p:cNvPr id="9" name="Picture 8" descr="payment-methods.jpg"/>
+          <p:cNvPr id="9" name="Picture 8" descr="payment-methods.png"/>
           <p:cNvPicPr>
             <a:picLocks noChangeAspect="1"/>
           </p:cNvPicPr>
@@ -6123,7 +6123,7 @@
       </p:sp>
       <p:pic>
         <p:nvPicPr>
-          <p:cNvPr id="11" name="Picture 10" descr="review-total.jpg"/>
+          <p:cNvPr id="11" name="Picture 10" descr="review-total.png"/>
           <p:cNvPicPr>
             <a:picLocks noChangeAspect="1"/>
           </p:cNvPicPr>
@@ -6255,7 +6255,7 @@
       </p:pic>
       <p:pic>
         <p:nvPicPr>
-          <p:cNvPr id="15" name="Picture 14" descr="cancellation-success.jpg"/>
+          <p:cNvPr id="15" name="Picture 14" descr="cancellation-success.png"/>
           <p:cNvPicPr>
             <a:picLocks noChangeAspect="1"/>
           </p:cNvPicPr>
@@ -9717,7 +9717,7 @@
       </p:sp>
       <p:pic>
         <p:nvPicPr>
-          <p:cNvPr id="9" name="Picture 8" descr="review-total.jpg"/>
+          <p:cNvPr id="9" name="Picture 8" descr="review-total.png"/>
           <p:cNvPicPr>
             <a:picLocks noChangeAspect="1"/>
           </p:cNvPicPr>
@@ -9862,45 +9862,30 @@
           </a:p>
         </p:txBody>
       </p:sp>
-      <p:sp>
-        <p:nvSpPr>
-          <p:cNvPr id="13" name="TextBox 12"/>
-          <p:cNvSpPr txBox="1"/>
-          <p:nvPr/>
-        </p:nvSpPr>
-        <p:spPr>
-          <a:xfrm>
-            <a:off x="6565392" y="1865376"/>
-            <a:ext cx="4480560" cy="475488"/>
-          </a:xfrm>
-          <a:prstGeom prst="rect">
-            <a:avLst/>
-          </a:prstGeom>
-          <a:noFill/>
-        </p:spPr>
-        <p:txBody>
-          <a:bodyPr wrap="square" lIns="18288" rIns="18288" tIns="18288" bIns="18288">
-            <a:spAutoFit/>
-          </a:bodyPr>
-          <a:lstStyle/>
-          <a:p>
-            <a:pPr>
-              <a:spcAft>
-                <a:spcPts val="500"/>
-              </a:spcAft>
-              <a:defRPr sz="2400" b="1">
-                <a:solidFill>
-                  <a:srgbClr val="1B222B"/>
-                </a:solidFill>
-                <a:latin typeface="Aptos"/>
-              </a:defRPr>
-            </a:pPr>
-            <a:r>
-              <a:t>Review your order</a:t>
-            </a:r>
-          </a:p>
-        </p:txBody>
-      </p:sp>
+      <p:pic>
+        <p:nvPicPr>
+          <p:cNvPr id="13" name="Picture 12" descr="screen-05.png"/>
+          <p:cNvPicPr>
+            <a:picLocks noChangeAspect="1"/>
+          </p:cNvPicPr>
+          <p:nvPr/>
+        </p:nvPicPr>
+        <p:blipFill>
+          <a:blip r:embed="rId4"/>
+          <a:stretch>
+            <a:fillRect/>
+          </a:stretch>
+        </p:blipFill>
+        <p:spPr>
+          <a:xfrm>
+            <a:off x="6419088" y="1901952"/>
+            <a:ext cx="4864608" cy="2736342"/>
+          </a:xfrm>
+          <a:prstGeom prst="rect">
+            <a:avLst/>
+          </a:prstGeom>
+        </p:spPr>
+      </p:pic>
       <p:sp>
         <p:nvSpPr>
           <p:cNvPr id="14" name="TextBox 13"/>
@@ -9909,161 +9894,8 @@
         </p:nvSpPr>
         <p:spPr>
           <a:xfrm>
-            <a:off x="6565392" y="2496312"/>
-            <a:ext cx="4517136" cy="1298448"/>
-          </a:xfrm>
-          <a:prstGeom prst="rect">
-            <a:avLst/>
-          </a:prstGeom>
-          <a:noFill/>
-        </p:spPr>
-        <p:txBody>
-          <a:bodyPr wrap="square" lIns="18288" rIns="18288" tIns="18288" bIns="18288">
-            <a:spAutoFit/>
-          </a:bodyPr>
-          <a:lstStyle/>
-          <a:p>
-            <a:pPr>
-              <a:spcAft>
-                <a:spcPts val="500"/>
-              </a:spcAft>
-              <a:defRPr sz="1800" b="0">
-                <a:solidFill>
-                  <a:srgbClr val="1B222B"/>
-                </a:solidFill>
-                <a:latin typeface="Aptos"/>
-              </a:defRPr>
-            </a:pPr>
-            <a:r>
-              <a:t>Item                                      ₹207</a:t>
-            </a:r>
-          </a:p>
-          <a:p>
-            <a:pPr>
-              <a:spcAft>
-                <a:spcPts val="500"/>
-              </a:spcAft>
-              <a:defRPr sz="1800" b="0">
-                <a:solidFill>
-                  <a:srgbClr val="1B222B"/>
-                </a:solidFill>
-                <a:latin typeface="Aptos"/>
-              </a:defRPr>
-            </a:pPr>
-            <a:r>
-              <a:t>Delivery                                FREE</a:t>
-            </a:r>
-          </a:p>
-          <a:p>
-            <a:pPr>
-              <a:spcAft>
-                <a:spcPts val="500"/>
-              </a:spcAft>
-              <a:defRPr sz="1800" b="0">
-                <a:solidFill>
-                  <a:srgbClr val="1B222B"/>
-                </a:solidFill>
-                <a:latin typeface="Aptos"/>
-              </a:defRPr>
-            </a:pPr>
-            <a:r>
-              <a:t>Cash on delivery fee                 ₹7</a:t>
-            </a:r>
-          </a:p>
-        </p:txBody>
-      </p:sp>
-      <p:sp>
-        <p:nvSpPr>
-          <p:cNvPr id="15" name="Rectangle 14"/>
-          <p:cNvSpPr/>
-          <p:nvPr/>
-        </p:nvSpPr>
-        <p:spPr>
-          <a:xfrm>
-            <a:off x="6537960" y="3849624"/>
-            <a:ext cx="4498848" cy="14630"/>
-          </a:xfrm>
-          <a:prstGeom prst="rect">
-            <a:avLst/>
-          </a:prstGeom>
-          <a:solidFill>
-            <a:srgbClr val="DAD7D1"/>
-          </a:solidFill>
-          <a:ln>
-            <a:noFill/>
-          </a:ln>
-        </p:spPr>
-        <p:style>
-          <a:lnRef idx="1">
-            <a:schemeClr val="accent1"/>
-          </a:lnRef>
-          <a:fillRef idx="3">
-            <a:schemeClr val="accent1"/>
-          </a:fillRef>
-          <a:effectRef idx="2">
-            <a:schemeClr val="accent1"/>
-          </a:effectRef>
-          <a:fontRef idx="minor">
-            <a:schemeClr val="lt1"/>
-          </a:fontRef>
-        </p:style>
-        <p:txBody>
-          <a:bodyPr rtlCol="0" anchor="ctr"/>
-          <a:lstStyle/>
-          <a:p>
-            <a:pPr algn="ctr"/>
-          </a:p>
-        </p:txBody>
-      </p:sp>
-      <p:sp>
-        <p:nvSpPr>
-          <p:cNvPr id="16" name="TextBox 15"/>
-          <p:cNvSpPr txBox="1"/>
-          <p:nvPr/>
-        </p:nvSpPr>
-        <p:spPr>
-          <a:xfrm>
-            <a:off x="6565392" y="3986784"/>
-            <a:ext cx="4517136" cy="365760"/>
-          </a:xfrm>
-          <a:prstGeom prst="rect">
-            <a:avLst/>
-          </a:prstGeom>
-          <a:noFill/>
-        </p:spPr>
-        <p:txBody>
-          <a:bodyPr wrap="square" lIns="18288" rIns="18288" tIns="18288" bIns="18288">
-            <a:spAutoFit/>
-          </a:bodyPr>
-          <a:lstStyle/>
-          <a:p>
-            <a:pPr>
-              <a:spcAft>
-                <a:spcPts val="500"/>
-              </a:spcAft>
-              <a:defRPr sz="2000" b="1">
-                <a:solidFill>
-                  <a:srgbClr val="1B222B"/>
-                </a:solidFill>
-                <a:latin typeface="Aptos"/>
-              </a:defRPr>
-            </a:pPr>
-            <a:r>
-              <a:t>Total payable                         ₹214</a:t>
-            </a:r>
-          </a:p>
-        </p:txBody>
-      </p:sp>
-      <p:sp>
-        <p:nvSpPr>
-          <p:cNvPr id="17" name="TextBox 16"/>
-          <p:cNvSpPr txBox="1"/>
-          <p:nvPr/>
-        </p:nvSpPr>
-        <p:spPr>
-          <a:xfrm>
-            <a:off x="6565392" y="4544568"/>
-            <a:ext cx="4553712" cy="320040"/>
+            <a:off x="6473952" y="4681728"/>
+            <a:ext cx="4690872" cy="320040"/>
           </a:xfrm>
           <a:prstGeom prst="rect">
             <a:avLst/>
@@ -10088,14 +9920,14 @@
               </a:defRPr>
             </a:pPr>
             <a:r>
-              <a:t>Edit address   ·   Edit payment   ·   Retry safely</a:t>
-            </a:r>
-          </a:p>
-        </p:txBody>
-      </p:sp>
-      <p:sp>
-        <p:nvSpPr>
-          <p:cNvPr id="18" name="TextBox 17"/>
+              <a:t>Clear fee · explicit total · direct Edit actions</a:t>
+            </a:r>
+          </a:p>
+        </p:txBody>
+      </p:sp>
+      <p:sp>
+        <p:nvSpPr>
+          <p:cNvPr id="15" name="TextBox 14"/>
           <p:cNvSpPr txBox="1"/>
           <p:nvPr/>
         </p:nvSpPr>

</xml_diff>